<commit_message>
Recorded commit ids updated after the history rewrite (same trees); run history with the commits each part of the run used; deliverables, deck, PDFs and the ElevenLabs-narrated video regenerated; explorer screenshots of the verified contracts
</commit_message>
<xml_diff>
--- a/deck/InternationalAI-TeamMongolia-Deck.pptx
+++ b/deck/InternationalAI-TeamMongolia-Deck.pptx
@@ -1218,7 +1218,7 @@
           <a:lstStyle/>
           <a:p>
             <a:r>
-              <a:t>[00:25] For on-chain exploration: we use the official ERC-8004 registries, a Draft standard, and check their pinned implementations before the run. Anyone can recompute a grade. The bureau accepts only vaults with our exact code and configuration. Grade upgrades wait a delay, and mandates pin payout wallets on-chain.</a:t>
+              <a:t>[00:25] For on-chain exploration: we use the official ERC-8004 registries, a Draft standard, and check their pinned implementations before the run. Contract sources are verified on Blockscout. Anyone can recompute a grade. The bureau accepts only vaults with our exact code and configuration. Grade upgrades wait a delay, and mandates pin payout wallets on-chain.</a:t>
             </a:r>
           </a:p>
         </p:txBody>
@@ -6247,7 +6247,7 @@
                 </a:solidFill>
                 <a:latin typeface="Arial"/>
               </a:rPr>
-              <a:t>Suite run r-20261017-122958 on anvil, commit 07eb9ef3323c. Stolen-key reverts on Base Sepolia: grade gate </a:t>
+              <a:t>Suite run r-20261018-052202 on anvil, commit 8ef8e40dc42f. Stolen-key reverts on Base Sepolia: grade gate </a:t>
             </a:r>
             <a:r>
               <a:rPr sz="1200" b="0" u="sng">
@@ -7358,7 +7358,7 @@
         </p:nvSpPr>
         <p:spPr>
           <a:xfrm>
-            <a:off x="7772400" y="4572000"/>
+            <a:off x="7772400" y="4882896"/>
             <a:ext cx="3886200" cy="566928"/>
           </a:xfrm>
           <a:prstGeom prst="roundRect">
@@ -8823,7 +8823,7 @@
         <p:spPr>
           <a:xfrm>
             <a:off x="1234440" y="1325880"/>
-            <a:ext cx="5852160" cy="822960"/>
+            <a:ext cx="5852160" cy="786384"/>
           </a:xfrm>
           <a:prstGeom prst="roundRect">
             <a:avLst>
@@ -8888,7 +8888,7 @@
         </p:nvSpPr>
         <p:spPr>
           <a:xfrm>
-            <a:off x="548640" y="2441448"/>
+            <a:off x="548640" y="2404872"/>
             <a:ext cx="548640" cy="548640"/>
           </a:xfrm>
           <a:prstGeom prst="ellipse">
@@ -8950,8 +8950,8 @@
         </p:nvSpPr>
         <p:spPr>
           <a:xfrm>
-            <a:off x="1234440" y="2331720"/>
-            <a:ext cx="5852160" cy="822960"/>
+            <a:off x="1234440" y="2295144"/>
+            <a:ext cx="5852160" cy="786384"/>
           </a:xfrm>
           <a:prstGeom prst="roundRect">
             <a:avLst>
@@ -9003,16 +9003,7 @@
                 </a:solidFill>
                 <a:latin typeface="Arial"/>
               </a:rPr>
-              <a:t>Permissionless recompute: </a:t>
-            </a:r>
-            <a:r>
-              <a:rPr sz="1800" b="0">
-                <a:solidFill>
-                  <a:srgbClr val="1E2235"/>
-                </a:solidFill>
-                <a:latin typeface="Courier New"/>
-              </a:rPr>
-              <a:t>acb bureau recompute --tx &lt;hash&gt;</a:t>
+              <a:t>Contract sources verified on Blockscout</a:t>
             </a:r>
           </a:p>
         </p:txBody>
@@ -9025,7 +9016,7 @@
         </p:nvSpPr>
         <p:spPr>
           <a:xfrm>
-            <a:off x="548640" y="3447288"/>
+            <a:off x="548640" y="3374136"/>
             <a:ext cx="548640" cy="548640"/>
           </a:xfrm>
           <a:prstGeom prst="ellipse">
@@ -9087,8 +9078,8 @@
         </p:nvSpPr>
         <p:spPr>
           <a:xfrm>
-            <a:off x="1234440" y="3337560"/>
-            <a:ext cx="5852160" cy="822960"/>
+            <a:off x="1234440" y="3264408"/>
+            <a:ext cx="5852160" cy="786384"/>
           </a:xfrm>
           <a:prstGeom prst="roundRect">
             <a:avLst>
@@ -9140,7 +9131,16 @@
                 </a:solidFill>
                 <a:latin typeface="Arial"/>
               </a:rPr>
-              <a:t>Vault registry bound to code and config (BadVaultCode, BadVaultConfig)</a:t>
+              <a:t>Permissionless recompute: </a:t>
+            </a:r>
+            <a:r>
+              <a:rPr sz="1800" b="0">
+                <a:solidFill>
+                  <a:srgbClr val="1E2235"/>
+                </a:solidFill>
+                <a:latin typeface="Courier New"/>
+              </a:rPr>
+              <a:t>acb bureau recompute --tx &lt;hash&gt;</a:t>
             </a:r>
           </a:p>
         </p:txBody>
@@ -9153,7 +9153,7 @@
         </p:nvSpPr>
         <p:spPr>
           <a:xfrm>
-            <a:off x="548640" y="4453128"/>
+            <a:off x="548640" y="4343400"/>
             <a:ext cx="548640" cy="548640"/>
           </a:xfrm>
           <a:prstGeom prst="ellipse">
@@ -9215,8 +9215,8 @@
         </p:nvSpPr>
         <p:spPr>
           <a:xfrm>
-            <a:off x="1234440" y="4343400"/>
-            <a:ext cx="5852160" cy="822960"/>
+            <a:off x="1234440" y="4233672"/>
+            <a:ext cx="5852160" cy="786384"/>
           </a:xfrm>
           <a:prstGeom prst="roundRect">
             <a:avLst>
@@ -9268,6 +9268,134 @@
                 </a:solidFill>
                 <a:latin typeface="Arial"/>
               </a:rPr>
+              <a:t>Vault registry bound to code and config (BadVaultCode, BadVaultConfig)</a:t>
+            </a:r>
+          </a:p>
+        </p:txBody>
+      </p:sp>
+      <p:sp>
+        <p:nvSpPr>
+          <p:cNvPr id="11" name="Oval 10"/>
+          <p:cNvSpPr/>
+          <p:nvPr/>
+        </p:nvSpPr>
+        <p:spPr>
+          <a:xfrm>
+            <a:off x="548640" y="5312664"/>
+            <a:ext cx="548640" cy="548640"/>
+          </a:xfrm>
+          <a:prstGeom prst="ellipse">
+            <a:avLst/>
+          </a:prstGeom>
+          <a:solidFill>
+            <a:srgbClr val="6779C6"/>
+          </a:solidFill>
+          <a:ln>
+            <a:noFill/>
+          </a:ln>
+          <a:effectLst/>
+        </p:spPr>
+        <p:style>
+          <a:lnRef idx="1">
+            <a:schemeClr val="accent1"/>
+          </a:lnRef>
+          <a:fillRef idx="3">
+            <a:schemeClr val="accent1"/>
+          </a:fillRef>
+          <a:effectRef idx="2">
+            <a:schemeClr val="accent1"/>
+          </a:effectRef>
+          <a:fontRef idx="minor">
+            <a:schemeClr val="lt1"/>
+          </a:fontRef>
+        </p:style>
+        <p:txBody>
+          <a:bodyPr rtlCol="0" anchor="ctr" wrap="square" lIns="0" rIns="0" tIns="36576" bIns="36576">
+            <a:noAutofit/>
+          </a:bodyPr>
+          <a:lstStyle/>
+          <a:p>
+            <a:pPr algn="ctr">
+              <a:lnSpc>
+                <a:spcPct val="100000"/>
+              </a:lnSpc>
+              <a:spcAft>
+                <a:spcPts val="0"/>
+              </a:spcAft>
+            </a:pPr>
+            <a:r>
+              <a:rPr sz="1800" b="1">
+                <a:solidFill>
+                  <a:srgbClr val="FFFFFF"/>
+                </a:solidFill>
+                <a:latin typeface="Arial"/>
+              </a:rPr>
+              <a:t>5</a:t>
+            </a:r>
+          </a:p>
+        </p:txBody>
+      </p:sp>
+      <p:sp>
+        <p:nvSpPr>
+          <p:cNvPr id="12" name="Rounded Rectangle 11"/>
+          <p:cNvSpPr/>
+          <p:nvPr/>
+        </p:nvSpPr>
+        <p:spPr>
+          <a:xfrm>
+            <a:off x="1234440" y="5202936"/>
+            <a:ext cx="5852160" cy="786384"/>
+          </a:xfrm>
+          <a:prstGeom prst="roundRect">
+            <a:avLst>
+              <a:gd name="adj" fmla="val 6000"/>
+            </a:avLst>
+          </a:prstGeom>
+          <a:solidFill>
+            <a:srgbClr val="F2F4FB"/>
+          </a:solidFill>
+          <a:ln w="12700">
+            <a:solidFill>
+              <a:srgbClr val="CDD3EC"/>
+            </a:solidFill>
+          </a:ln>
+          <a:effectLst/>
+        </p:spPr>
+        <p:style>
+          <a:lnRef idx="1">
+            <a:schemeClr val="accent1"/>
+          </a:lnRef>
+          <a:fillRef idx="3">
+            <a:schemeClr val="accent1"/>
+          </a:fillRef>
+          <a:effectRef idx="2">
+            <a:schemeClr val="accent1"/>
+          </a:effectRef>
+          <a:fontRef idx="minor">
+            <a:schemeClr val="lt1"/>
+          </a:fontRef>
+        </p:style>
+        <p:txBody>
+          <a:bodyPr rtlCol="0" anchor="ctr" wrap="square" lIns="109728" rIns="109728" tIns="36576" bIns="36576">
+            <a:noAutofit/>
+          </a:bodyPr>
+          <a:lstStyle/>
+          <a:p>
+            <a:pPr algn="l">
+              <a:lnSpc>
+                <a:spcPct val="100000"/>
+              </a:lnSpc>
+              <a:spcAft>
+                <a:spcPts val="0"/>
+              </a:spcAft>
+            </a:pPr>
+            <a:r>
+              <a:rPr sz="1800" b="0">
+                <a:solidFill>
+                  <a:srgbClr val="1E2235"/>
+                </a:solidFill>
+                <a:latin typeface="Arial"/>
+              </a:rPr>
               <a:t>Delayed grade upgrades; on-chain mandates with pinned payout wallets</a:t>
             </a:r>
           </a:p>
@@ -9275,7 +9403,7 @@
       </p:sp>
       <p:sp>
         <p:nvSpPr>
-          <p:cNvPr id="11" name="Rounded Rectangle 10"/>
+          <p:cNvPr id="13" name="Rounded Rectangle 12"/>
           <p:cNvSpPr/>
           <p:nvPr/>
         </p:nvSpPr>
@@ -9323,7 +9451,7 @@
       </p:sp>
       <p:sp>
         <p:nvSpPr>
-          <p:cNvPr id="12" name="TextBox 11"/>
+          <p:cNvPr id="14" name="TextBox 13"/>
           <p:cNvSpPr txBox="1"/>
           <p:nvPr/>
         </p:nvSpPr>
@@ -9365,7 +9493,7 @@
       </p:sp>
       <p:sp>
         <p:nvSpPr>
-          <p:cNvPr id="13" name="TextBox 12"/>
+          <p:cNvPr id="15" name="TextBox 14"/>
           <p:cNvSpPr txBox="1"/>
           <p:nvPr/>
         </p:nvSpPr>
@@ -9407,7 +9535,7 @@
       </p:sp>
       <p:sp>
         <p:nvSpPr>
-          <p:cNvPr id="14" name="TextBox 13"/>
+          <p:cNvPr id="16" name="TextBox 15"/>
           <p:cNvSpPr txBox="1"/>
           <p:nvPr/>
         </p:nvSpPr>
@@ -9449,7 +9577,7 @@
       </p:sp>
       <p:sp>
         <p:nvSpPr>
-          <p:cNvPr id="15" name="Rounded Rectangle 14"/>
+          <p:cNvPr id="17" name="Rounded Rectangle 16"/>
           <p:cNvSpPr/>
           <p:nvPr/>
         </p:nvSpPr>
@@ -9532,7 +9660,7 @@
       </p:sp>
       <p:sp>
         <p:nvSpPr>
-          <p:cNvPr id="16" name="Footer"/>
+          <p:cNvPr id="18" name="Footer"/>
           <p:cNvSpPr txBox="1"/>
           <p:nvPr/>
         </p:nvSpPr>
@@ -23420,15 +23548,9 @@
                         </a:rPr>
                         <a:t>0xdd46a8...902e</a:t>
                       </a:r>
-                      <a:r>
-                        <a:rPr sz="1300" b="0">
-                          <a:solidFill>
-                            <a:srgbClr val="1E2235"/>
-                          </a:solidFill>
-                          <a:latin typeface="Arial"/>
-                        </a:rPr>
-                        <a:t>, </a:t>
-                      </a:r>
+                    </a:p>
+                    <a:p>
+                      <a:pPr algn="l"/>
                       <a:r>
                         <a:rPr sz="1300" b="0" u="sng">
                           <a:solidFill>
@@ -23511,15 +23633,9 @@
                         </a:rPr>
                         <a:t>0x36bdc1...4e7d</a:t>
                       </a:r>
-                      <a:r>
-                        <a:rPr sz="1300" b="0">
-                          <a:solidFill>
-                            <a:srgbClr val="1E2235"/>
-                          </a:solidFill>
-                          <a:latin typeface="Arial"/>
-                        </a:rPr>
-                        <a:t>, </a:t>
-                      </a:r>
+                    </a:p>
+                    <a:p>
+                      <a:pPr algn="l"/>
                       <a:r>
                         <a:rPr sz="1300" b="0" u="sng">
                           <a:solidFill>
@@ -23530,15 +23646,9 @@
                         </a:rPr>
                         <a:t>0x3c0165...76af</a:t>
                       </a:r>
-                      <a:r>
-                        <a:rPr sz="1300" b="0">
-                          <a:solidFill>
-                            <a:srgbClr val="1E2235"/>
-                          </a:solidFill>
-                          <a:latin typeface="Arial"/>
-                        </a:rPr>
-                        <a:t>, </a:t>
-                      </a:r>
+                    </a:p>
+                    <a:p>
+                      <a:pPr algn="l"/>
                       <a:r>
                         <a:rPr sz="1300" b="0" u="sng">
                           <a:solidFill>
@@ -23621,15 +23731,9 @@
                         </a:rPr>
                         <a:t>0xae242f...12a0</a:t>
                       </a:r>
-                      <a:r>
-                        <a:rPr sz="1300" b="0">
-                          <a:solidFill>
-                            <a:srgbClr val="1E2235"/>
-                          </a:solidFill>
-                          <a:latin typeface="Arial"/>
-                        </a:rPr>
-                        <a:t>, </a:t>
-                      </a:r>
+                    </a:p>
+                    <a:p>
+                      <a:pPr algn="l"/>
                       <a:r>
                         <a:rPr sz="1300" b="0" u="sng">
                           <a:solidFill>
@@ -23712,15 +23816,9 @@
                         </a:rPr>
                         <a:t>0x2a829d...9de0</a:t>
                       </a:r>
-                      <a:r>
-                        <a:rPr sz="1300" b="0">
-                          <a:solidFill>
-                            <a:srgbClr val="1E2235"/>
-                          </a:solidFill>
-                          <a:latin typeface="Arial"/>
-                        </a:rPr>
-                        <a:t>, </a:t>
-                      </a:r>
+                    </a:p>
+                    <a:p>
+                      <a:pPr algn="l"/>
                       <a:r>
                         <a:rPr sz="1300" b="0" u="sng">
                           <a:solidFill>
@@ -23731,15 +23829,9 @@
                         </a:rPr>
                         <a:t>0x555966...c636</a:t>
                       </a:r>
-                      <a:r>
-                        <a:rPr sz="1300" b="0">
-                          <a:solidFill>
-                            <a:srgbClr val="1E2235"/>
-                          </a:solidFill>
-                          <a:latin typeface="Arial"/>
-                        </a:rPr>
-                        <a:t>, </a:t>
-                      </a:r>
+                    </a:p>
+                    <a:p>
+                      <a:pPr algn="l"/>
                       <a:r>
                         <a:rPr sz="1300" b="0" u="sng">
                           <a:solidFill>

</xml_diff>